<commit_message>
Pitch deck: updated slides and numbers audit, PDF export, logo concepts
- omnitrix_pitch.pptx and numbers_audit.md updated; omnitrix_pitch.pdf
  is the deck as a PDF.
- Logo: three mark concepts (A tiers, B approve, C sweep), the A
  lockup and a small icon, as SVG and PNG, plus a concepts overview.

Co-Authored-By: Claude Opus 5.5 <noreply@anthropic.com>
</commit_message>
<xml_diff>
--- a/Claude outputs/pitch-deck/omnitrix_pitch.pptx
+++ b/Claude outputs/pitch-deck/omnitrix_pitch.pptx
@@ -1377,7 +1377,7 @@
           <a:lstStyle/>
           <a:p>
             <a:r>
-              <a:t>Our work lives in email, meetings and notes, and today's AI memory tools fail it in three ways. They store junk: an audit of 10,134 Mem0 memories found 97.8% junk. They judge silently: Graphiti's small-model judge invalidated 41% of about 3,950 facts, and 3 of 4 audited cases were wrong. Or they send everything to the cloud: even careful local + cloud delegation leaks private data on 7.5% of queries (PAPILLON).</a:t>
+              <a:t>The problem is data overload plus unreliable AI memory. First, context is fragmented: the decisions that matter are buried across scattered emails, calendar invites and messy notes. Second, today's memory frameworks break: an audit of 10,134 Mem0 memories found 97.8% junk, and Graphiti's small-model judge silently invalidated 41% of about 3,950 facts, with 3 of 4 audited cases wrong. Third, privacy: even careful local + cloud delegation leaks private data on 7.5% of queries (PAPILLON).</a:t>
             </a:r>
           </a:p>
         </p:txBody>
@@ -5355,8 +5355,8 @@
         </p:nvSpPr>
         <p:spPr>
           <a:xfrm>
-            <a:off x="548640" y="502920"/>
-            <a:ext cx="11094415" cy="731520"/>
+            <a:off x="548640" y="457200"/>
+            <a:ext cx="11091672" cy="1188720"/>
           </a:xfrm>
           <a:prstGeom prst="rect">
             <a:avLst/>
@@ -5377,8 +5377,11 @@
                 </a:solidFill>
                 <a:latin typeface="Calibri"/>
               </a:rPr>
-              <a:t>Buried in email. </a:t>
-            </a:r>
+              <a:t>The Problem:</a:t>
+            </a:r>
+          </a:p>
+          <a:p>
+            <a:pPr algn="ctr"/>
             <a:r>
               <a:rPr sz="3600" b="0" i="0">
                 <a:solidFill>
@@ -5386,220 +5389,25 @@
                 </a:solidFill>
                 <a:latin typeface="Calibri"/>
               </a:rPr>
-              <a:t>Failed by AI memory.</a:t>
-            </a:r>
-          </a:p>
-        </p:txBody>
-      </p:sp>
-      <p:pic>
-        <p:nvPicPr>
-          <p:cNvPr id="4" name="Picture 3" descr="mail icon"/>
-          <p:cNvPicPr>
-            <a:picLocks noChangeAspect="1"/>
-          </p:cNvPicPr>
-          <p:nvPr/>
-        </p:nvPicPr>
-        <p:blipFill>
-          <a:blip r:embed="rId3">
-            <a:extLst>
-              <a:ext uri="{96DAC541-7B7A-43D3-8B79-37D633B846F1}">
-                <asvg:svgBlip xmlns:asvg="http://schemas.microsoft.com/office/drawing/2016/SVG/main" r:embed="rId4"/>
-              </a:ext>
-            </a:extLst>
-          </a:blip>
-          <a:stretch>
-            <a:fillRect/>
-          </a:stretch>
-        </p:blipFill>
-        <p:spPr>
-          <a:xfrm>
-            <a:off x="4152748" y="1444752"/>
-            <a:ext cx="274320" cy="274320"/>
-          </a:xfrm>
-          <a:prstGeom prst="rect">
-            <a:avLst/>
-          </a:prstGeom>
-        </p:spPr>
-      </p:pic>
-      <p:sp>
-        <p:nvSpPr>
-          <p:cNvPr id="5" name="TextBox 4"/>
-          <p:cNvSpPr txBox="1"/>
-          <p:nvPr/>
-        </p:nvSpPr>
-        <p:spPr>
-          <a:xfrm>
-            <a:off x="4518508" y="1444752"/>
-            <a:ext cx="594360" cy="274320"/>
-          </a:xfrm>
-          <a:prstGeom prst="rect">
-            <a:avLst/>
-          </a:prstGeom>
-          <a:noFill/>
-        </p:spPr>
-        <p:txBody>
-          <a:bodyPr wrap="square" lIns="0" rIns="0" tIns="0" bIns="0" anchor="ctr">
-            <a:spAutoFit/>
-          </a:bodyPr>
-          <a:lstStyle/>
-          <a:p>
-            <a:pPr algn="l"/>
-            <a:r>
-              <a:rPr sz="1400" b="0" i="0">
-                <a:solidFill>
-                  <a:srgbClr val="E6E6E6"/>
-                </a:solidFill>
-                <a:latin typeface="Calibri"/>
-              </a:rPr>
-              <a:t>Email</a:t>
-            </a:r>
-          </a:p>
-        </p:txBody>
-      </p:sp>
-      <p:pic>
-        <p:nvPicPr>
-          <p:cNvPr id="6" name="Picture 5" descr="calendar icon"/>
-          <p:cNvPicPr>
-            <a:picLocks noChangeAspect="1"/>
-          </p:cNvPicPr>
-          <p:nvPr/>
-        </p:nvPicPr>
-        <p:blipFill>
-          <a:blip r:embed="rId5">
-            <a:extLst>
-              <a:ext uri="{96DAC541-7B7A-43D3-8B79-37D633B846F1}">
-                <asvg:svgBlip xmlns:asvg="http://schemas.microsoft.com/office/drawing/2016/SVG/main" r:embed="rId6"/>
-              </a:ext>
-            </a:extLst>
-          </a:blip>
-          <a:stretch>
-            <a:fillRect/>
-          </a:stretch>
-        </p:blipFill>
-        <p:spPr>
-          <a:xfrm>
-            <a:off x="5478628" y="1444752"/>
-            <a:ext cx="274320" cy="274320"/>
-          </a:xfrm>
-          <a:prstGeom prst="rect">
-            <a:avLst/>
-          </a:prstGeom>
-        </p:spPr>
-      </p:pic>
-      <p:sp>
-        <p:nvSpPr>
-          <p:cNvPr id="7" name="TextBox 6"/>
-          <p:cNvSpPr txBox="1"/>
-          <p:nvPr/>
-        </p:nvSpPr>
-        <p:spPr>
-          <a:xfrm>
-            <a:off x="5844388" y="1444752"/>
-            <a:ext cx="914400" cy="274320"/>
-          </a:xfrm>
-          <a:prstGeom prst="rect">
-            <a:avLst/>
-          </a:prstGeom>
-          <a:noFill/>
-        </p:spPr>
-        <p:txBody>
-          <a:bodyPr wrap="square" lIns="0" rIns="0" tIns="0" bIns="0" anchor="ctr">
-            <a:spAutoFit/>
-          </a:bodyPr>
-          <a:lstStyle/>
-          <a:p>
-            <a:pPr algn="l"/>
-            <a:r>
-              <a:rPr sz="1400" b="0" i="0">
-                <a:solidFill>
-                  <a:srgbClr val="E6E6E6"/>
-                </a:solidFill>
-                <a:latin typeface="Calibri"/>
-              </a:rPr>
-              <a:t>Meetings</a:t>
-            </a:r>
-          </a:p>
-        </p:txBody>
-      </p:sp>
-      <p:pic>
-        <p:nvPicPr>
-          <p:cNvPr id="8" name="Picture 7" descr="notes icon"/>
-          <p:cNvPicPr>
-            <a:picLocks noChangeAspect="1"/>
-          </p:cNvPicPr>
-          <p:nvPr/>
-        </p:nvPicPr>
-        <p:blipFill>
-          <a:blip r:embed="rId7">
-            <a:extLst>
-              <a:ext uri="{96DAC541-7B7A-43D3-8B79-37D633B846F1}">
-                <asvg:svgBlip xmlns:asvg="http://schemas.microsoft.com/office/drawing/2016/SVG/main" r:embed="rId8"/>
-              </a:ext>
-            </a:extLst>
-          </a:blip>
-          <a:stretch>
-            <a:fillRect/>
-          </a:stretch>
-        </p:blipFill>
-        <p:spPr>
-          <a:xfrm>
-            <a:off x="7124548" y="1444752"/>
-            <a:ext cx="274320" cy="274320"/>
-          </a:xfrm>
-          <a:prstGeom prst="rect">
-            <a:avLst/>
-          </a:prstGeom>
-        </p:spPr>
-      </p:pic>
-      <p:sp>
-        <p:nvSpPr>
-          <p:cNvPr id="9" name="TextBox 8"/>
-          <p:cNvSpPr txBox="1"/>
-          <p:nvPr/>
-        </p:nvSpPr>
-        <p:spPr>
-          <a:xfrm>
-            <a:off x="7490308" y="1444752"/>
-            <a:ext cx="640080" cy="274320"/>
-          </a:xfrm>
-          <a:prstGeom prst="rect">
-            <a:avLst/>
-          </a:prstGeom>
-          <a:noFill/>
-        </p:spPr>
-        <p:txBody>
-          <a:bodyPr wrap="square" lIns="0" rIns="0" tIns="0" bIns="0" anchor="ctr">
-            <a:spAutoFit/>
-          </a:bodyPr>
-          <a:lstStyle/>
-          <a:p>
-            <a:pPr algn="l"/>
-            <a:r>
-              <a:rPr sz="1400" b="0" i="0">
-                <a:solidFill>
-                  <a:srgbClr val="E6E6E6"/>
-                </a:solidFill>
-                <a:latin typeface="Calibri"/>
-              </a:rPr>
-              <a:t>Notes</a:t>
-            </a:r>
-          </a:p>
-        </p:txBody>
-      </p:sp>
-      <p:sp>
-        <p:nvSpPr>
-          <p:cNvPr id="10" name="Rounded Rectangle 9"/>
+              <a:t>Data Overload &amp; Unreliable AI Memory</a:t>
+            </a:r>
+          </a:p>
+        </p:txBody>
+      </p:sp>
+      <p:sp>
+        <p:nvSpPr>
+          <p:cNvPr id="4" name="Rounded Rectangle 3"/>
           <p:cNvSpPr/>
           <p:nvPr/>
         </p:nvSpPr>
         <p:spPr>
           <a:xfrm>
-            <a:off x="562356" y="2103120"/>
-            <a:ext cx="3474720" cy="3429000"/>
+            <a:off x="562356" y="1828800"/>
+            <a:ext cx="3474720" cy="3657600"/>
           </a:xfrm>
           <a:prstGeom prst="roundRect">
             <a:avLst>
-              <a:gd name="adj" fmla="val 3200"/>
+              <a:gd name="adj" fmla="val 3157"/>
             </a:avLst>
           </a:prstGeom>
           <a:solidFill>
@@ -5634,17 +5442,17 @@
       </p:sp>
       <p:pic>
         <p:nvPicPr>
-          <p:cNvPr id="11" name="Picture 10" descr="trash icon"/>
+          <p:cNvPr id="5" name="Picture 4" descr="layers icon"/>
           <p:cNvPicPr>
             <a:picLocks noChangeAspect="1"/>
           </p:cNvPicPr>
           <p:nvPr/>
         </p:nvPicPr>
         <p:blipFill>
-          <a:blip r:embed="rId9">
+          <a:blip r:embed="rId3">
             <a:extLst>
               <a:ext uri="{96DAC541-7B7A-43D3-8B79-37D633B846F1}">
-                <asvg:svgBlip xmlns:asvg="http://schemas.microsoft.com/office/drawing/2016/SVG/main" r:embed="rId10"/>
+                <asvg:svgBlip xmlns:asvg="http://schemas.microsoft.com/office/drawing/2016/SVG/main" r:embed="rId4"/>
               </a:ext>
             </a:extLst>
           </a:blip>
@@ -5654,8 +5462,8 @@
         </p:blipFill>
         <p:spPr>
           <a:xfrm>
-            <a:off x="2025396" y="2377440"/>
-            <a:ext cx="548640" cy="548640"/>
+            <a:off x="836676" y="2103120"/>
+            <a:ext cx="347472" cy="347472"/>
           </a:xfrm>
           <a:prstGeom prst="rect">
             <a:avLst/>
@@ -5664,14 +5472,14 @@
       </p:pic>
       <p:sp>
         <p:nvSpPr>
-          <p:cNvPr id="12" name="TextBox 11"/>
+          <p:cNvPr id="6" name="TextBox 5"/>
           <p:cNvSpPr txBox="1"/>
           <p:nvPr/>
         </p:nvSpPr>
         <p:spPr>
           <a:xfrm>
-            <a:off x="836676" y="3063240"/>
-            <a:ext cx="2926080" cy="320040"/>
+            <a:off x="1293876" y="2103120"/>
+            <a:ext cx="2560320" cy="347472"/>
           </a:xfrm>
           <a:prstGeom prst="rect">
             <a:avLst/>
@@ -5684,57 +5492,22 @@
           </a:bodyPr>
           <a:lstStyle/>
           <a:p>
-            <a:pPr algn="ctr"/>
+            <a:pPr algn="l"/>
             <a:r>
               <a:rPr sz="1600" b="1" i="0">
                 <a:solidFill>
-                  <a:srgbClr val="E6E6E6"/>
-                </a:solidFill>
-                <a:latin typeface="Calibri"/>
-              </a:rPr>
-              <a:t>Stores junk</a:t>
-            </a:r>
-          </a:p>
-        </p:txBody>
-      </p:sp>
-      <p:sp>
-        <p:nvSpPr>
-          <p:cNvPr id="13" name="TextBox 12"/>
-          <p:cNvSpPr txBox="1"/>
-          <p:nvPr/>
-        </p:nvSpPr>
-        <p:spPr>
-          <a:xfrm>
-            <a:off x="745236" y="3474720"/>
-            <a:ext cx="3108960" cy="868680"/>
-          </a:xfrm>
-          <a:prstGeom prst="rect">
-            <a:avLst/>
-          </a:prstGeom>
-          <a:noFill/>
-        </p:spPr>
-        <p:txBody>
-          <a:bodyPr wrap="square" lIns="0" rIns="0" tIns="0" bIns="0" anchor="ctr">
-            <a:spAutoFit/>
-          </a:bodyPr>
-          <a:lstStyle/>
-          <a:p>
-            <a:pPr algn="ctr"/>
-            <a:r>
-              <a:rPr sz="6000" b="1" i="0">
-                <a:solidFill>
                   <a:srgbClr val="FFFFFF"/>
                 </a:solidFill>
                 <a:latin typeface="Calibri"/>
               </a:rPr>
-              <a:t>97.8%</a:t>
-            </a:r>
-          </a:p>
-        </p:txBody>
-      </p:sp>
-      <p:sp>
-        <p:nvSpPr>
-          <p:cNvPr id="14" name="TextBox 13"/>
+              <a:t>Context fragmentation</a:t>
+            </a:r>
+          </a:p>
+        </p:txBody>
+      </p:sp>
+      <p:sp>
+        <p:nvSpPr>
+          <p:cNvPr id="7" name="TextBox 6"/>
           <p:cNvSpPr txBox="1"/>
           <p:nvPr/>
         </p:nvSpPr>
@@ -5756,31 +5529,31 @@
           <a:p>
             <a:pPr algn="ctr"/>
             <a:r>
-              <a:rPr sz="1250" b="0" i="0">
+              <a:rPr sz="1300" b="0" i="0">
                 <a:solidFill>
                   <a:srgbClr val="A0A0A0"/>
                 </a:solidFill>
                 <a:latin typeface="Calibri"/>
               </a:rPr>
-              <a:t>of 10,134 audited Mem0 memories</a:t>
-            </a:r>
-          </a:p>
-        </p:txBody>
-      </p:sp>
-      <p:sp>
-        <p:nvSpPr>
-          <p:cNvPr id="15" name="Rounded Rectangle 14"/>
+              <a:t>Decisions scattered across emails, calendar invites and notes</a:t>
+            </a:r>
+          </a:p>
+        </p:txBody>
+      </p:sp>
+      <p:sp>
+        <p:nvSpPr>
+          <p:cNvPr id="8" name="Rounded Rectangle 7"/>
           <p:cNvSpPr/>
           <p:nvPr/>
         </p:nvSpPr>
         <p:spPr>
           <a:xfrm>
-            <a:off x="4357116" y="2103120"/>
-            <a:ext cx="3474720" cy="3429000"/>
+            <a:off x="4357116" y="1828800"/>
+            <a:ext cx="3474720" cy="3657600"/>
           </a:xfrm>
           <a:prstGeom prst="roundRect">
             <a:avLst>
-              <a:gd name="adj" fmla="val 3200"/>
+              <a:gd name="adj" fmla="val 3157"/>
             </a:avLst>
           </a:prstGeom>
           <a:solidFill>
@@ -5815,17 +5588,17 @@
       </p:sp>
       <p:pic>
         <p:nvPicPr>
-          <p:cNvPr id="16" name="Picture 15" descr="eyeoff icon"/>
+          <p:cNvPr id="9" name="Picture 8" descr="trash icon"/>
           <p:cNvPicPr>
             <a:picLocks noChangeAspect="1"/>
           </p:cNvPicPr>
           <p:nvPr/>
         </p:nvPicPr>
         <p:blipFill>
-          <a:blip r:embed="rId11">
+          <a:blip r:embed="rId5">
             <a:extLst>
               <a:ext uri="{96DAC541-7B7A-43D3-8B79-37D633B846F1}">
-                <asvg:svgBlip xmlns:asvg="http://schemas.microsoft.com/office/drawing/2016/SVG/main" r:embed="rId12"/>
+                <asvg:svgBlip xmlns:asvg="http://schemas.microsoft.com/office/drawing/2016/SVG/main" r:embed="rId6"/>
               </a:ext>
             </a:extLst>
           </a:blip>
@@ -5835,8 +5608,8 @@
         </p:blipFill>
         <p:spPr>
           <a:xfrm>
-            <a:off x="5820156" y="2377440"/>
-            <a:ext cx="548640" cy="548640"/>
+            <a:off x="4631436" y="2103120"/>
+            <a:ext cx="347472" cy="347472"/>
           </a:xfrm>
           <a:prstGeom prst="rect">
             <a:avLst/>
@@ -5845,14 +5618,14 @@
       </p:pic>
       <p:sp>
         <p:nvSpPr>
-          <p:cNvPr id="17" name="TextBox 16"/>
+          <p:cNvPr id="10" name="TextBox 9"/>
           <p:cNvSpPr txBox="1"/>
           <p:nvPr/>
         </p:nvSpPr>
         <p:spPr>
           <a:xfrm>
-            <a:off x="4631436" y="3063240"/>
-            <a:ext cx="2926080" cy="320040"/>
+            <a:off x="5088636" y="2103120"/>
+            <a:ext cx="2560320" cy="347472"/>
           </a:xfrm>
           <a:prstGeom prst="rect">
             <a:avLst/>
@@ -5865,57 +5638,22 @@
           </a:bodyPr>
           <a:lstStyle/>
           <a:p>
-            <a:pPr algn="ctr"/>
+            <a:pPr algn="l"/>
             <a:r>
               <a:rPr sz="1600" b="1" i="0">
                 <a:solidFill>
-                  <a:srgbClr val="E6E6E6"/>
-                </a:solidFill>
-                <a:latin typeface="Calibri"/>
-              </a:rPr>
-              <a:t>Judges silently</a:t>
-            </a:r>
-          </a:p>
-        </p:txBody>
-      </p:sp>
-      <p:sp>
-        <p:nvSpPr>
-          <p:cNvPr id="18" name="TextBox 17"/>
-          <p:cNvSpPr txBox="1"/>
-          <p:nvPr/>
-        </p:nvSpPr>
-        <p:spPr>
-          <a:xfrm>
-            <a:off x="4539996" y="3474720"/>
-            <a:ext cx="3108960" cy="868680"/>
-          </a:xfrm>
-          <a:prstGeom prst="rect">
-            <a:avLst/>
-          </a:prstGeom>
-          <a:noFill/>
-        </p:spPr>
-        <p:txBody>
-          <a:bodyPr wrap="square" lIns="0" rIns="0" tIns="0" bIns="0" anchor="ctr">
-            <a:spAutoFit/>
-          </a:bodyPr>
-          <a:lstStyle/>
-          <a:p>
-            <a:pPr algn="ctr"/>
-            <a:r>
-              <a:rPr sz="6000" b="1" i="0">
-                <a:solidFill>
                   <a:srgbClr val="FFFFFF"/>
                 </a:solidFill>
                 <a:latin typeface="Calibri"/>
               </a:rPr>
-              <a:t>41%</a:t>
-            </a:r>
-          </a:p>
-        </p:txBody>
-      </p:sp>
-      <p:sp>
-        <p:nvSpPr>
-          <p:cNvPr id="19" name="TextBox 18"/>
+              <a:t>Broken AI memory</a:t>
+            </a:r>
+          </a:p>
+        </p:txBody>
+      </p:sp>
+      <p:sp>
+        <p:nvSpPr>
+          <p:cNvPr id="11" name="TextBox 10"/>
           <p:cNvSpPr txBox="1"/>
           <p:nvPr/>
         </p:nvSpPr>
@@ -5937,31 +5675,31 @@
           <a:p>
             <a:pPr algn="ctr"/>
             <a:r>
-              <a:rPr sz="1250" b="0" i="0">
+              <a:rPr sz="1300" b="0" i="0">
                 <a:solidFill>
                   <a:srgbClr val="A0A0A0"/>
                 </a:solidFill>
                 <a:latin typeface="Calibri"/>
               </a:rPr>
-              <a:t>of ~3,950 facts invalidated by Graphiti's small judge; 3 of 4 audited were wrong</a:t>
-            </a:r>
-          </a:p>
-        </p:txBody>
-      </p:sp>
-      <p:sp>
-        <p:nvSpPr>
-          <p:cNvPr id="20" name="Rounded Rectangle 19"/>
+              <a:t>3 of 4 audited invalidations were wrong</a:t>
+            </a:r>
+          </a:p>
+        </p:txBody>
+      </p:sp>
+      <p:sp>
+        <p:nvSpPr>
+          <p:cNvPr id="12" name="Rounded Rectangle 11"/>
           <p:cNvSpPr/>
           <p:nvPr/>
         </p:nvSpPr>
         <p:spPr>
           <a:xfrm>
-            <a:off x="8151876" y="2103120"/>
-            <a:ext cx="3474720" cy="3429000"/>
+            <a:off x="8151876" y="1828800"/>
+            <a:ext cx="3474720" cy="3657600"/>
           </a:xfrm>
           <a:prstGeom prst="roundRect">
             <a:avLst>
-              <a:gd name="adj" fmla="val 3200"/>
+              <a:gd name="adj" fmla="val 3157"/>
             </a:avLst>
           </a:prstGeom>
           <a:solidFill>
@@ -5996,7 +5734,237 @@
       </p:sp>
       <p:pic>
         <p:nvPicPr>
-          <p:cNvPr id="21" name="Picture 20" descr="cloudup icon"/>
+          <p:cNvPr id="13" name="Picture 12" descr="cloudup icon"/>
+          <p:cNvPicPr>
+            <a:picLocks noChangeAspect="1"/>
+          </p:cNvPicPr>
+          <p:nvPr/>
+        </p:nvPicPr>
+        <p:blipFill>
+          <a:blip r:embed="rId7">
+            <a:extLst>
+              <a:ext uri="{96DAC541-7B7A-43D3-8B79-37D633B846F1}">
+                <asvg:svgBlip xmlns:asvg="http://schemas.microsoft.com/office/drawing/2016/SVG/main" r:embed="rId8"/>
+              </a:ext>
+            </a:extLst>
+          </a:blip>
+          <a:stretch>
+            <a:fillRect/>
+          </a:stretch>
+        </p:blipFill>
+        <p:spPr>
+          <a:xfrm>
+            <a:off x="8426196" y="2103120"/>
+            <a:ext cx="347472" cy="347472"/>
+          </a:xfrm>
+          <a:prstGeom prst="rect">
+            <a:avLst/>
+          </a:prstGeom>
+        </p:spPr>
+      </p:pic>
+      <p:sp>
+        <p:nvSpPr>
+          <p:cNvPr id="14" name="TextBox 13"/>
+          <p:cNvSpPr txBox="1"/>
+          <p:nvPr/>
+        </p:nvSpPr>
+        <p:spPr>
+          <a:xfrm>
+            <a:off x="8883396" y="2103120"/>
+            <a:ext cx="2560320" cy="347472"/>
+          </a:xfrm>
+          <a:prstGeom prst="rect">
+            <a:avLst/>
+          </a:prstGeom>
+          <a:noFill/>
+        </p:spPr>
+        <p:txBody>
+          <a:bodyPr wrap="square" lIns="0" rIns="0" tIns="0" bIns="0" anchor="ctr">
+            <a:spAutoFit/>
+          </a:bodyPr>
+          <a:lstStyle/>
+          <a:p>
+            <a:pPr algn="l"/>
+            <a:r>
+              <a:rPr sz="1600" b="1" i="0">
+                <a:solidFill>
+                  <a:srgbClr val="FFFFFF"/>
+                </a:solidFill>
+                <a:latin typeface="Calibri"/>
+              </a:rPr>
+              <a:t>Privacy leaks</a:t>
+            </a:r>
+          </a:p>
+        </p:txBody>
+      </p:sp>
+      <p:sp>
+        <p:nvSpPr>
+          <p:cNvPr id="15" name="TextBox 14"/>
+          <p:cNvSpPr txBox="1"/>
+          <p:nvPr/>
+        </p:nvSpPr>
+        <p:spPr>
+          <a:xfrm>
+            <a:off x="8471916" y="4434840"/>
+            <a:ext cx="2834640" cy="822960"/>
+          </a:xfrm>
+          <a:prstGeom prst="rect">
+            <a:avLst/>
+          </a:prstGeom>
+          <a:noFill/>
+        </p:spPr>
+        <p:txBody>
+          <a:bodyPr wrap="square" lIns="0" rIns="0" tIns="0" bIns="0" anchor="t">
+            <a:spAutoFit/>
+          </a:bodyPr>
+          <a:lstStyle/>
+          <a:p>
+            <a:pPr algn="ctr"/>
+            <a:r>
+              <a:rPr sz="1300" b="0" i="0">
+                <a:solidFill>
+                  <a:srgbClr val="A0A0A0"/>
+                </a:solidFill>
+                <a:latin typeface="Calibri"/>
+              </a:rPr>
+              <a:t>of queries leak private data in local + cloud delegation (PAPILLON)</a:t>
+            </a:r>
+          </a:p>
+        </p:txBody>
+      </p:sp>
+      <p:pic>
+        <p:nvPicPr>
+          <p:cNvPr id="16" name="Picture 15" descr="mail icon"/>
+          <p:cNvPicPr>
+            <a:picLocks noChangeAspect="1"/>
+          </p:cNvPicPr>
+          <p:nvPr/>
+        </p:nvPicPr>
+        <p:blipFill>
+          <a:blip r:embed="rId9">
+            <a:extLst>
+              <a:ext uri="{96DAC541-7B7A-43D3-8B79-37D633B846F1}">
+                <asvg:svgBlip xmlns:asvg="http://schemas.microsoft.com/office/drawing/2016/SVG/main" r:embed="rId10"/>
+              </a:ext>
+            </a:extLst>
+          </a:blip>
+          <a:stretch>
+            <a:fillRect/>
+          </a:stretch>
+        </p:blipFill>
+        <p:spPr>
+          <a:xfrm>
+            <a:off x="1001268" y="2880360"/>
+            <a:ext cx="585216" cy="585216"/>
+          </a:xfrm>
+          <a:prstGeom prst="rect">
+            <a:avLst/>
+          </a:prstGeom>
+        </p:spPr>
+      </p:pic>
+      <p:sp>
+        <p:nvSpPr>
+          <p:cNvPr id="17" name="TextBox 16"/>
+          <p:cNvSpPr txBox="1"/>
+          <p:nvPr/>
+        </p:nvSpPr>
+        <p:spPr>
+          <a:xfrm>
+            <a:off x="790956" y="3566160"/>
+            <a:ext cx="1005840" cy="274320"/>
+          </a:xfrm>
+          <a:prstGeom prst="rect">
+            <a:avLst/>
+          </a:prstGeom>
+          <a:noFill/>
+        </p:spPr>
+        <p:txBody>
+          <a:bodyPr wrap="square" lIns="0" rIns="0" tIns="0" bIns="0" anchor="ctr">
+            <a:spAutoFit/>
+          </a:bodyPr>
+          <a:lstStyle/>
+          <a:p>
+            <a:pPr algn="ctr"/>
+            <a:r>
+              <a:rPr sz="1200" b="0" i="0">
+                <a:solidFill>
+                  <a:srgbClr val="E6E6E6"/>
+                </a:solidFill>
+                <a:latin typeface="Calibri"/>
+              </a:rPr>
+              <a:t>Emails</a:t>
+            </a:r>
+          </a:p>
+        </p:txBody>
+      </p:sp>
+      <p:pic>
+        <p:nvPicPr>
+          <p:cNvPr id="18" name="Picture 17" descr="calendar icon"/>
+          <p:cNvPicPr>
+            <a:picLocks noChangeAspect="1"/>
+          </p:cNvPicPr>
+          <p:nvPr/>
+        </p:nvPicPr>
+        <p:blipFill>
+          <a:blip r:embed="rId11">
+            <a:extLst>
+              <a:ext uri="{96DAC541-7B7A-43D3-8B79-37D633B846F1}">
+                <asvg:svgBlip xmlns:asvg="http://schemas.microsoft.com/office/drawing/2016/SVG/main" r:embed="rId12"/>
+              </a:ext>
+            </a:extLst>
+          </a:blip>
+          <a:stretch>
+            <a:fillRect/>
+          </a:stretch>
+        </p:blipFill>
+        <p:spPr>
+          <a:xfrm>
+            <a:off x="2007108" y="2880360"/>
+            <a:ext cx="585216" cy="585216"/>
+          </a:xfrm>
+          <a:prstGeom prst="rect">
+            <a:avLst/>
+          </a:prstGeom>
+        </p:spPr>
+      </p:pic>
+      <p:sp>
+        <p:nvSpPr>
+          <p:cNvPr id="19" name="TextBox 18"/>
+          <p:cNvSpPr txBox="1"/>
+          <p:nvPr/>
+        </p:nvSpPr>
+        <p:spPr>
+          <a:xfrm>
+            <a:off x="1796796" y="3566160"/>
+            <a:ext cx="1005840" cy="274320"/>
+          </a:xfrm>
+          <a:prstGeom prst="rect">
+            <a:avLst/>
+          </a:prstGeom>
+          <a:noFill/>
+        </p:spPr>
+        <p:txBody>
+          <a:bodyPr wrap="square" lIns="0" rIns="0" tIns="0" bIns="0" anchor="ctr">
+            <a:spAutoFit/>
+          </a:bodyPr>
+          <a:lstStyle/>
+          <a:p>
+            <a:pPr algn="ctr"/>
+            <a:r>
+              <a:rPr sz="1200" b="0" i="0">
+                <a:solidFill>
+                  <a:srgbClr val="E6E6E6"/>
+                </a:solidFill>
+                <a:latin typeface="Calibri"/>
+              </a:rPr>
+              <a:t>Invites</a:t>
+            </a:r>
+          </a:p>
+        </p:txBody>
+      </p:sp>
+      <p:pic>
+        <p:nvPicPr>
+          <p:cNvPr id="20" name="Picture 19" descr="notes icon"/>
           <p:cNvPicPr>
             <a:picLocks noChangeAspect="1"/>
           </p:cNvPicPr>
@@ -6016,8 +5984,8 @@
         </p:blipFill>
         <p:spPr>
           <a:xfrm>
-            <a:off x="9614916" y="2377440"/>
-            <a:ext cx="548640" cy="548640"/>
+            <a:off x="3012948" y="2880360"/>
+            <a:ext cx="585216" cy="585216"/>
           </a:xfrm>
           <a:prstGeom prst="rect">
             <a:avLst/>
@@ -6026,14 +5994,14 @@
       </p:pic>
       <p:sp>
         <p:nvSpPr>
-          <p:cNvPr id="22" name="TextBox 21"/>
+          <p:cNvPr id="21" name="TextBox 20"/>
           <p:cNvSpPr txBox="1"/>
           <p:nvPr/>
         </p:nvSpPr>
         <p:spPr>
           <a:xfrm>
-            <a:off x="8426196" y="3063240"/>
-            <a:ext cx="2926080" cy="320040"/>
+            <a:off x="2802636" y="3566160"/>
+            <a:ext cx="1005840" cy="274320"/>
           </a:xfrm>
           <a:prstGeom prst="rect">
             <a:avLst/>
@@ -6048,27 +6016,27 @@
           <a:p>
             <a:pPr algn="ctr"/>
             <a:r>
-              <a:rPr sz="1600" b="1" i="0">
+              <a:rPr sz="1200" b="0" i="0">
                 <a:solidFill>
                   <a:srgbClr val="E6E6E6"/>
                 </a:solidFill>
                 <a:latin typeface="Calibri"/>
               </a:rPr>
-              <a:t>Sends it to the cloud</a:t>
-            </a:r>
-          </a:p>
-        </p:txBody>
-      </p:sp>
-      <p:sp>
-        <p:nvSpPr>
-          <p:cNvPr id="23" name="TextBox 22"/>
+              <a:t>Notes</a:t>
+            </a:r>
+          </a:p>
+        </p:txBody>
+      </p:sp>
+      <p:sp>
+        <p:nvSpPr>
+          <p:cNvPr id="22" name="TextBox 21"/>
           <p:cNvSpPr txBox="1"/>
           <p:nvPr/>
         </p:nvSpPr>
         <p:spPr>
           <a:xfrm>
-            <a:off x="8334756" y="3474720"/>
-            <a:ext cx="3108960" cy="868680"/>
+            <a:off x="4539996" y="2788920"/>
+            <a:ext cx="1554480" cy="731520"/>
           </a:xfrm>
           <a:prstGeom prst="rect">
             <a:avLst/>
@@ -6083,27 +6051,27 @@
           <a:p>
             <a:pPr algn="ctr"/>
             <a:r>
-              <a:rPr sz="6000" b="1" i="0">
+              <a:rPr sz="4400" b="1" i="0">
                 <a:solidFill>
                   <a:srgbClr val="FFFFFF"/>
                 </a:solidFill>
                 <a:latin typeface="Calibri"/>
               </a:rPr>
-              <a:t>7.5%</a:t>
-            </a:r>
-          </a:p>
-        </p:txBody>
-      </p:sp>
-      <p:sp>
-        <p:nvSpPr>
-          <p:cNvPr id="24" name="TextBox 23"/>
+              <a:t>97.8%</a:t>
+            </a:r>
+          </a:p>
+        </p:txBody>
+      </p:sp>
+      <p:sp>
+        <p:nvSpPr>
+          <p:cNvPr id="23" name="TextBox 22"/>
           <p:cNvSpPr txBox="1"/>
           <p:nvPr/>
         </p:nvSpPr>
         <p:spPr>
           <a:xfrm>
-            <a:off x="8471916" y="4434840"/>
-            <a:ext cx="2834640" cy="822960"/>
+            <a:off x="4631436" y="3566160"/>
+            <a:ext cx="1371600" cy="502920"/>
           </a:xfrm>
           <a:prstGeom prst="rect">
             <a:avLst/>
@@ -6118,20 +6086,125 @@
           <a:p>
             <a:pPr algn="ctr"/>
             <a:r>
-              <a:rPr sz="1250" b="0" i="0">
-                <a:solidFill>
-                  <a:srgbClr val="A0A0A0"/>
-                </a:solidFill>
-                <a:latin typeface="Calibri"/>
-              </a:rPr>
-              <a:t>of queries leak private data, even with careful local + cloud (PAPILLON)</a:t>
-            </a:r>
-          </a:p>
-        </p:txBody>
-      </p:sp>
-      <p:sp>
-        <p:nvSpPr>
-          <p:cNvPr id="25" name="Footer"/>
+              <a:rPr sz="1200" b="0" i="0">
+                <a:solidFill>
+                  <a:srgbClr val="E6E6E6"/>
+                </a:solidFill>
+                <a:latin typeface="Calibri"/>
+              </a:rPr>
+              <a:t>junk in a Mem0 audit</a:t>
+            </a:r>
+          </a:p>
+        </p:txBody>
+      </p:sp>
+      <p:sp>
+        <p:nvSpPr>
+          <p:cNvPr id="24" name="TextBox 23"/>
+          <p:cNvSpPr txBox="1"/>
+          <p:nvPr/>
+        </p:nvSpPr>
+        <p:spPr>
+          <a:xfrm>
+            <a:off x="6094476" y="2788920"/>
+            <a:ext cx="1554480" cy="731520"/>
+          </a:xfrm>
+          <a:prstGeom prst="rect">
+            <a:avLst/>
+          </a:prstGeom>
+          <a:noFill/>
+        </p:spPr>
+        <p:txBody>
+          <a:bodyPr wrap="square" lIns="0" rIns="0" tIns="0" bIns="0" anchor="ctr">
+            <a:spAutoFit/>
+          </a:bodyPr>
+          <a:lstStyle/>
+          <a:p>
+            <a:pPr algn="ctr"/>
+            <a:r>
+              <a:rPr sz="4400" b="1" i="0">
+                <a:solidFill>
+                  <a:srgbClr val="FFFFFF"/>
+                </a:solidFill>
+                <a:latin typeface="Calibri"/>
+              </a:rPr>
+              <a:t>41%</a:t>
+            </a:r>
+          </a:p>
+        </p:txBody>
+      </p:sp>
+      <p:sp>
+        <p:nvSpPr>
+          <p:cNvPr id="25" name="TextBox 24"/>
+          <p:cNvSpPr txBox="1"/>
+          <p:nvPr/>
+        </p:nvSpPr>
+        <p:spPr>
+          <a:xfrm>
+            <a:off x="6185916" y="3566160"/>
+            <a:ext cx="1371600" cy="502920"/>
+          </a:xfrm>
+          <a:prstGeom prst="rect">
+            <a:avLst/>
+          </a:prstGeom>
+          <a:noFill/>
+        </p:spPr>
+        <p:txBody>
+          <a:bodyPr wrap="square" lIns="0" rIns="0" tIns="0" bIns="0" anchor="t">
+            <a:spAutoFit/>
+          </a:bodyPr>
+          <a:lstStyle/>
+          <a:p>
+            <a:pPr algn="ctr"/>
+            <a:r>
+              <a:rPr sz="1200" b="0" i="0">
+                <a:solidFill>
+                  <a:srgbClr val="E6E6E6"/>
+                </a:solidFill>
+                <a:latin typeface="Calibri"/>
+              </a:rPr>
+              <a:t>Graphiti facts invalidated</a:t>
+            </a:r>
+          </a:p>
+        </p:txBody>
+      </p:sp>
+      <p:sp>
+        <p:nvSpPr>
+          <p:cNvPr id="26" name="TextBox 25"/>
+          <p:cNvSpPr txBox="1"/>
+          <p:nvPr/>
+        </p:nvSpPr>
+        <p:spPr>
+          <a:xfrm>
+            <a:off x="8334756" y="2788920"/>
+            <a:ext cx="3108960" cy="1005840"/>
+          </a:xfrm>
+          <a:prstGeom prst="rect">
+            <a:avLst/>
+          </a:prstGeom>
+          <a:noFill/>
+        </p:spPr>
+        <p:txBody>
+          <a:bodyPr wrap="square" lIns="0" rIns="0" tIns="0" bIns="0" anchor="ctr">
+            <a:spAutoFit/>
+          </a:bodyPr>
+          <a:lstStyle/>
+          <a:p>
+            <a:pPr algn="ctr"/>
+            <a:r>
+              <a:rPr sz="6400" b="1" i="0">
+                <a:solidFill>
+                  <a:srgbClr val="FFFFFF"/>
+                </a:solidFill>
+                <a:latin typeface="Calibri"/>
+              </a:rPr>
+              <a:t>7.5%</a:t>
+            </a:r>
+          </a:p>
+        </p:txBody>
+      </p:sp>
+      <p:sp>
+        <p:nvSpPr>
+          <p:cNvPr id="27" name="Footer"/>
           <p:cNvSpPr txBox="1"/>
           <p:nvPr/>
         </p:nvSpPr>
@@ -10643,16 +10716,46 @@
           <a:p/>
         </p:txBody>
       </p:sp>
-      <p:sp>
-        <p:nvSpPr>
-          <p:cNvPr id="10" name="TextBox 9"/>
+      <p:pic>
+        <p:nvPicPr>
+          <p:cNvPr id="10" name="Picture 9" descr="users icon"/>
+          <p:cNvPicPr>
+            <a:picLocks noChangeAspect="1"/>
+          </p:cNvPicPr>
+          <p:nvPr/>
+        </p:nvPicPr>
+        <p:blipFill>
+          <a:blip r:embed="rId4">
+            <a:extLst>
+              <a:ext uri="{96DAC541-7B7A-43D3-8B79-37D633B846F1}">
+                <asvg:svgBlip xmlns:asvg="http://schemas.microsoft.com/office/drawing/2016/SVG/main" r:embed="rId5"/>
+              </a:ext>
+            </a:extLst>
+          </a:blip>
+          <a:stretch>
+            <a:fillRect/>
+          </a:stretch>
+        </p:blipFill>
+        <p:spPr>
+          <a:xfrm>
+            <a:off x="7952537" y="3968496"/>
+            <a:ext cx="402336" cy="402336"/>
+          </a:xfrm>
+          <a:prstGeom prst="rect">
+            <a:avLst/>
+          </a:prstGeom>
+        </p:spPr>
+      </p:pic>
+      <p:sp>
+        <p:nvSpPr>
+          <p:cNvPr id="11" name="TextBox 10"/>
           <p:cNvSpPr txBox="1"/>
           <p:nvPr/>
         </p:nvSpPr>
         <p:spPr>
           <a:xfrm>
-            <a:off x="6233465" y="3931920"/>
-            <a:ext cx="3840480" cy="502920"/>
+            <a:off x="6233465" y="4434840"/>
+            <a:ext cx="3840480" cy="320040"/>
           </a:xfrm>
           <a:prstGeom prst="rect">
             <a:avLst/>
@@ -10667,48 +10770,13 @@
           <a:p>
             <a:pPr algn="ctr"/>
             <a:r>
-              <a:rPr sz="1700" b="1" i="0">
-                <a:solidFill>
-                  <a:srgbClr val="FFFFFF"/>
-                </a:solidFill>
-                <a:latin typeface="Calibri"/>
-              </a:rPr>
-              <a:t>TODO: team contact</a:t>
-            </a:r>
-          </a:p>
-        </p:txBody>
-      </p:sp>
-      <p:sp>
-        <p:nvSpPr>
-          <p:cNvPr id="11" name="TextBox 10"/>
-          <p:cNvSpPr txBox="1"/>
-          <p:nvPr/>
-        </p:nvSpPr>
-        <p:spPr>
-          <a:xfrm>
-            <a:off x="6233465" y="4434840"/>
-            <a:ext cx="3840480" cy="320040"/>
-          </a:xfrm>
-          <a:prstGeom prst="rect">
-            <a:avLst/>
-          </a:prstGeom>
-          <a:noFill/>
-        </p:spPr>
-        <p:txBody>
-          <a:bodyPr wrap="square" lIns="0" rIns="0" tIns="0" bIns="0" anchor="ctr">
-            <a:spAutoFit/>
-          </a:bodyPr>
-          <a:lstStyle/>
-          <a:p>
-            <a:pPr algn="ctr"/>
-            <a:r>
               <a:rPr sz="1100" b="0" i="0">
                 <a:solidFill>
                   <a:srgbClr val="A0A0A0"/>
                 </a:solidFill>
                 <a:latin typeface="Calibri"/>
               </a:rPr>
-              <a:t>Contact</a:t>
+              <a:t>Team</a:t>
             </a:r>
           </a:p>
         </p:txBody>

</xml_diff>